<commit_message>
chore: remove closing line and date/time from presentation deck
Co-Authored-By: Claude Sonnet 4.6 <noreply@anthropic.com>
</commit_message>
<xml_diff>
--- a/dhaga-returns-intelligence.pptx
+++ b/dhaga-returns-intelligence.pptx
@@ -3204,7 +3204,7 @@
                   <a:srgbClr val="FF6B6B"/>
                 </a:solidFill>
               </a:rPr>
-              <a:t>Group 4  ·  Sat 3 Oct  ·  5:45 PM</a:t>
+              <a:t>Group 4</a:t>
             </a:r>
           </a:p>
         </p:txBody>
@@ -4656,41 +4656,6 @@
                 </a:solidFill>
               </a:rPr>
               <a:t>To test whether supplier-level patterns are visible before we build across all 40.</a:t>
-            </a:r>
-          </a:p>
-        </p:txBody>
-      </p:sp>
-      <p:sp>
-        <p:nvSpPr>
-          <p:cNvPr id="13" name="TextBox 12"/>
-          <p:cNvSpPr txBox="1"/>
-          <p:nvPr/>
-        </p:nvSpPr>
-        <p:spPr>
-          <a:xfrm>
-            <a:off x="457200" y="5577840"/>
-            <a:ext cx="11247120" cy="640080"/>
-          </a:xfrm>
-          <a:prstGeom prst="rect">
-            <a:avLst/>
-          </a:prstGeom>
-          <a:noFill/>
-        </p:spPr>
-        <p:txBody>
-          <a:bodyPr wrap="square">
-            <a:spAutoFit/>
-          </a:bodyPr>
-          <a:lstStyle/>
-          <a:p>
-            <a:pPr algn="ctr"/>
-            <a:r>
-              <a:rPr sz="1600" b="0" i="1">
-                <a:solidFill>
-                  <a:srgbClr val="FFD700"/>
-                </a:solidFill>
-              </a:rPr>
-              <a:t>The signal is already in your data. You have 18 months of reviews and 11 million orders
-that have never been asked this question.</a:t>
             </a:r>
           </a:p>
         </p:txBody>

</xml_diff>